<commit_message>
fix(pptx): aligne le PowerPoint avec le README mis à jour
Slides modifiés :
- Slide 14 : Agent Sessions View + subagents + local/background/cloud
- Slide 16 : 6 stratégies tokens (ajout Caveman Mode)
- Slide 17 : NOUVEAU slide Caveman Mode exercice live
- Slide 19 : Roadmap repositionnée (multi-agent = natif maintenant)

Co-authored-by: Copilot <223556219+Copilot@users.noreply.github.com>
</commit_message>
<xml_diff>
--- a/community-forum-2/Community-Forum-2.pptx
+++ b/community-forum-2/Community-Forum-2.pptx
@@ -21,6 +21,7 @@
     <p:sldId id="269" r:id="rId21"/>
     <p:sldId id="270" r:id="rId22"/>
     <p:sldId id="271" r:id="rId23"/>
+    <p:sldId id="286" r:id="rId38"/>
     <p:sldId id="272" r:id="rId24"/>
     <p:sldId id="273" r:id="rId25"/>
     <p:sldId id="274" r:id="rId26"/>
@@ -7861,7 +7862,7 @@
         <p:spPr>
           <a:xfrm>
             <a:off x="457200" y="274320"/>
-            <a:ext cx="10972800" cy="731520"/>
+            <a:ext cx="8229600" cy="914400"/>
           </a:xfrm>
           <a:prstGeom prst="rect">
             <a:avLst/>
@@ -7874,409 +7875,306 @@
           </a:bodyPr>
           <a:lstStyle/>
           <a:p>
-            <a:pPr algn="l">
-              <a:defRPr sz="3600" b="1">
-                <a:solidFill>
-                  <a:srgbClr val="E94560"/>
-                </a:solidFill>
-              </a:defRPr>
-            </a:pPr>
-            <a:r>
-              <a:t>🔀 Agent Orchestration</a:t>
-            </a:r>
-          </a:p>
-        </p:txBody>
-      </p:sp>
-      <p:sp>
-        <p:nvSpPr>
-          <p:cNvPr id="3" name="Rounded Rectangle 2"/>
-          <p:cNvSpPr/>
-          <p:nvPr/>
-        </p:nvSpPr>
-        <p:spPr>
-          <a:xfrm>
-            <a:off x="4114800" y="1188720"/>
-            <a:ext cx="4114800" cy="914400"/>
-          </a:xfrm>
-          <a:prstGeom prst="roundRect">
-            <a:avLst/>
-          </a:prstGeom>
-          <a:solidFill>
-            <a:srgbClr val="2A1A2E"/>
-          </a:solidFill>
-          <a:ln w="19050">
-            <a:solidFill>
-              <a:srgbClr val="E94560"/>
-            </a:solidFill>
-          </a:ln>
-        </p:spPr>
-        <p:style>
-          <a:lnRef idx="1">
-            <a:schemeClr val="accent1"/>
-          </a:lnRef>
-          <a:fillRef idx="3">
-            <a:schemeClr val="accent1"/>
-          </a:fillRef>
-          <a:effectRef idx="2">
-            <a:schemeClr val="accent1"/>
-          </a:effectRef>
-          <a:fontRef idx="minor">
-            <a:schemeClr val="lt1"/>
-          </a:fontRef>
-        </p:style>
-        <p:txBody>
-          <a:bodyPr rtlCol="0" anchor="ctr" wrap="square"/>
-          <a:lstStyle/>
-          <a:p>
-            <a:pPr algn="ctr">
-              <a:defRPr sz="1300">
+            <a:pPr>
+              <a:defRPr sz="2800" b="1">
                 <a:solidFill>
                   <a:srgbClr val="FFFFFF"/>
                 </a:solidFill>
               </a:defRPr>
             </a:pPr>
             <a:r>
-              <a:t>🧠 Main Agent — Decomposes &amp; delegates</a:t>
-            </a:r>
-          </a:p>
-        </p:txBody>
-      </p:sp>
-      <p:sp>
-        <p:nvSpPr>
-          <p:cNvPr id="4" name="Rounded Rectangle 3"/>
-          <p:cNvSpPr/>
-          <p:nvPr/>
-        </p:nvSpPr>
-        <p:spPr>
-          <a:xfrm>
-            <a:off x="274320" y="2926080"/>
-            <a:ext cx="2743200" cy="1097280"/>
-          </a:xfrm>
-          <a:prstGeom prst="roundRect">
-            <a:avLst/>
-          </a:prstGeom>
-          <a:solidFill>
-            <a:srgbClr val="16213E"/>
-          </a:solidFill>
-          <a:ln w="19050">
-            <a:solidFill>
-              <a:srgbClr val="E94560"/>
-            </a:solidFill>
-          </a:ln>
-        </p:spPr>
-        <p:style>
-          <a:lnRef idx="1">
-            <a:schemeClr val="accent1"/>
-          </a:lnRef>
-          <a:fillRef idx="3">
-            <a:schemeClr val="accent1"/>
-          </a:fillRef>
-          <a:effectRef idx="2">
-            <a:schemeClr val="accent1"/>
-          </a:effectRef>
-          <a:fontRef idx="minor">
-            <a:schemeClr val="lt1"/>
-          </a:fontRef>
-        </p:style>
-        <p:txBody>
-          <a:bodyPr rtlCol="0" anchor="ctr" wrap="square"/>
-          <a:lstStyle/>
-          <a:p>
-            <a:pPr algn="ctr">
-              <a:defRPr sz="1200">
-                <a:solidFill>
-                  <a:srgbClr val="E94560"/>
-                </a:solidFill>
-              </a:defRPr>
-            </a:pPr>
-            <a:r>
-              <a:t>🔍 Explore</a:t>
-            </a:r>
-            <a:br/>
-            <a:r>
-              <a:t>Analyze code</a:t>
-            </a:r>
-          </a:p>
-        </p:txBody>
-      </p:sp>
-      <p:sp>
-        <p:nvSpPr>
-          <p:cNvPr id="5" name="Rounded Rectangle 4"/>
-          <p:cNvSpPr/>
-          <p:nvPr/>
-        </p:nvSpPr>
-        <p:spPr>
-          <a:xfrm>
-            <a:off x="3200400" y="2926080"/>
-            <a:ext cx="2743200" cy="1097280"/>
-          </a:xfrm>
-          <a:prstGeom prst="roundRect">
-            <a:avLst/>
-          </a:prstGeom>
-          <a:solidFill>
-            <a:srgbClr val="16213E"/>
-          </a:solidFill>
-          <a:ln w="19050">
-            <a:solidFill>
-              <a:srgbClr val="4FACFE"/>
-            </a:solidFill>
-          </a:ln>
-        </p:spPr>
-        <p:style>
-          <a:lnRef idx="1">
-            <a:schemeClr val="accent1"/>
-          </a:lnRef>
-          <a:fillRef idx="3">
-            <a:schemeClr val="accent1"/>
-          </a:fillRef>
-          <a:effectRef idx="2">
-            <a:schemeClr val="accent1"/>
-          </a:effectRef>
-          <a:fontRef idx="minor">
-            <a:schemeClr val="lt1"/>
-          </a:fontRef>
-        </p:style>
-        <p:txBody>
-          <a:bodyPr rtlCol="0" anchor="ctr" wrap="square"/>
-          <a:lstStyle/>
-          <a:p>
-            <a:pPr algn="ctr">
-              <a:defRPr sz="1200">
-                <a:solidFill>
-                  <a:srgbClr val="4FACFE"/>
-                </a:solidFill>
-              </a:defRPr>
-            </a:pPr>
-            <a:r>
-              <a:t>🛠️ Task</a:t>
-            </a:r>
-            <a:br/>
-            <a:r>
-              <a:t>Fix / Implement</a:t>
-            </a:r>
-          </a:p>
-        </p:txBody>
-      </p:sp>
-      <p:sp>
-        <p:nvSpPr>
-          <p:cNvPr id="6" name="Rounded Rectangle 5"/>
-          <p:cNvSpPr/>
-          <p:nvPr/>
-        </p:nvSpPr>
-        <p:spPr>
-          <a:xfrm>
-            <a:off x="6126480" y="2926080"/>
-            <a:ext cx="2743200" cy="1097280"/>
-          </a:xfrm>
-          <a:prstGeom prst="roundRect">
-            <a:avLst/>
-          </a:prstGeom>
-          <a:solidFill>
-            <a:srgbClr val="16213E"/>
-          </a:solidFill>
-          <a:ln w="19050">
-            <a:solidFill>
-              <a:srgbClr val="2ED573"/>
-            </a:solidFill>
-          </a:ln>
-        </p:spPr>
-        <p:style>
-          <a:lnRef idx="1">
-            <a:schemeClr val="accent1"/>
-          </a:lnRef>
-          <a:fillRef idx="3">
-            <a:schemeClr val="accent1"/>
-          </a:fillRef>
-          <a:effectRef idx="2">
-            <a:schemeClr val="accent1"/>
-          </a:effectRef>
-          <a:fontRef idx="minor">
-            <a:schemeClr val="lt1"/>
-          </a:fontRef>
-        </p:style>
-        <p:txBody>
-          <a:bodyPr rtlCol="0" anchor="ctr" wrap="square"/>
-          <a:lstStyle/>
-          <a:p>
-            <a:pPr algn="ctr">
-              <a:defRPr sz="1200">
-                <a:solidFill>
-                  <a:srgbClr val="2ED573"/>
-                </a:solidFill>
-              </a:defRPr>
-            </a:pPr>
-            <a:r>
-              <a:t>🧪 Test</a:t>
-            </a:r>
-            <a:br/>
-            <a:r>
-              <a:t>Write &amp; run tests</a:t>
-            </a:r>
-          </a:p>
-        </p:txBody>
-      </p:sp>
-      <p:sp>
-        <p:nvSpPr>
-          <p:cNvPr id="7" name="Rounded Rectangle 6"/>
-          <p:cNvSpPr/>
-          <p:nvPr/>
-        </p:nvSpPr>
-        <p:spPr>
-          <a:xfrm>
-            <a:off x="9052560" y="2926080"/>
-            <a:ext cx="2743200" cy="1097280"/>
-          </a:xfrm>
-          <a:prstGeom prst="roundRect">
-            <a:avLst/>
-          </a:prstGeom>
-          <a:solidFill>
-            <a:srgbClr val="16213E"/>
-          </a:solidFill>
-          <a:ln w="19050">
-            <a:solidFill>
-              <a:srgbClr val="FFC107"/>
-            </a:solidFill>
-          </a:ln>
-        </p:spPr>
-        <p:style>
-          <a:lnRef idx="1">
-            <a:schemeClr val="accent1"/>
-          </a:lnRef>
-          <a:fillRef idx="3">
-            <a:schemeClr val="accent1"/>
-          </a:fillRef>
-          <a:effectRef idx="2">
-            <a:schemeClr val="accent1"/>
-          </a:effectRef>
-          <a:fontRef idx="minor">
-            <a:schemeClr val="lt1"/>
-          </a:fontRef>
-        </p:style>
-        <p:txBody>
-          <a:bodyPr rtlCol="0" anchor="ctr" wrap="square"/>
-          <a:lstStyle/>
-          <a:p>
-            <a:pPr algn="ctr">
-              <a:defRPr sz="1200">
-                <a:solidFill>
-                  <a:srgbClr val="FFC107"/>
-                </a:solidFill>
-              </a:defRPr>
-            </a:pPr>
-            <a:r>
-              <a:t>📝 Review</a:t>
-            </a:r>
-            <a:br/>
-            <a:r>
-              <a:t>Validate quality</a:t>
-            </a:r>
-          </a:p>
-        </p:txBody>
-      </p:sp>
-      <p:sp>
-        <p:nvSpPr>
-          <p:cNvPr id="8" name="Rounded Rectangle 7"/>
-          <p:cNvSpPr/>
-          <p:nvPr/>
-        </p:nvSpPr>
-        <p:spPr>
-          <a:xfrm>
-            <a:off x="274320" y="4389120"/>
-            <a:ext cx="11430000" cy="548640"/>
-          </a:xfrm>
-          <a:prstGeom prst="roundRect">
-            <a:avLst/>
-          </a:prstGeom>
-          <a:solidFill>
-            <a:srgbClr val="0F1F3A"/>
-          </a:solidFill>
-          <a:ln w="19050">
-            <a:solidFill>
-              <a:srgbClr val="4FACFE"/>
-            </a:solidFill>
-          </a:ln>
-        </p:spPr>
-        <p:style>
-          <a:lnRef idx="1">
-            <a:schemeClr val="accent1"/>
-          </a:lnRef>
-          <a:fillRef idx="3">
-            <a:schemeClr val="accent1"/>
-          </a:fillRef>
-          <a:effectRef idx="2">
-            <a:schemeClr val="accent1"/>
-          </a:effectRef>
-          <a:fontRef idx="minor">
-            <a:schemeClr val="lt1"/>
-          </a:fontRef>
-        </p:style>
-        <p:txBody>
-          <a:bodyPr rtlCol="0" anchor="ctr" wrap="square"/>
-          <a:lstStyle/>
-          <a:p>
-            <a:pPr algn="ctr">
-              <a:defRPr sz="1200">
-                <a:solidFill>
-                  <a:srgbClr val="4FACFE"/>
-                </a:solidFill>
-              </a:defRPr>
-            </a:pPr>
-            <a:r>
-              <a:t>⚡ Parallel execution when tasks are independent</a:t>
-            </a:r>
-          </a:p>
-        </p:txBody>
-      </p:sp>
-      <p:sp>
-        <p:nvSpPr>
-          <p:cNvPr id="9" name="Rounded Rectangle 8"/>
-          <p:cNvSpPr/>
-          <p:nvPr/>
-        </p:nvSpPr>
-        <p:spPr>
-          <a:xfrm>
-            <a:off x="3200400" y="5303520"/>
-            <a:ext cx="5486400" cy="731520"/>
-          </a:xfrm>
-          <a:prstGeom prst="roundRect">
-            <a:avLst/>
-          </a:prstGeom>
-          <a:solidFill>
-            <a:srgbClr val="12251A"/>
-          </a:solidFill>
-          <a:ln w="19050">
-            <a:solidFill>
-              <a:srgbClr val="2ED573"/>
-            </a:solidFill>
-          </a:ln>
-        </p:spPr>
-        <p:style>
-          <a:lnRef idx="1">
-            <a:schemeClr val="accent1"/>
-          </a:lnRef>
-          <a:fillRef idx="3">
-            <a:schemeClr val="accent1"/>
-          </a:fillRef>
-          <a:effectRef idx="2">
-            <a:schemeClr val="accent1"/>
-          </a:effectRef>
-          <a:fontRef idx="minor">
-            <a:schemeClr val="lt1"/>
-          </a:fontRef>
-        </p:style>
-        <p:txBody>
-          <a:bodyPr rtlCol="0" anchor="ctr" wrap="square"/>
-          <a:lstStyle/>
-          <a:p>
-            <a:pPr algn="ctr">
-              <a:defRPr sz="1400">
-                <a:solidFill>
-                  <a:srgbClr val="2ED573"/>
-                </a:solidFill>
-              </a:defRPr>
-            </a:pPr>
-            <a:r>
-              <a:t>✅ Coordinated Output (PR, fix, report)</a:t>
+              <a:t>🔀 Multi-Agent Orchestration (VS Code 1.109+)</a:t>
+            </a:r>
+          </a:p>
+        </p:txBody>
+      </p:sp>
+      <p:sp>
+        <p:nvSpPr>
+          <p:cNvPr id="3" name="TextBox 2"/>
+          <p:cNvSpPr txBox="1"/>
+          <p:nvPr/>
+        </p:nvSpPr>
+        <p:spPr>
+          <a:xfrm>
+            <a:off x="457200" y="1188720"/>
+            <a:ext cx="8229600" cy="4572000"/>
+          </a:xfrm>
+          <a:prstGeom prst="rect">
+            <a:avLst/>
+          </a:prstGeom>
+          <a:noFill/>
+        </p:spPr>
+        <p:txBody>
+          <a:bodyPr wrap="square">
+            <a:spAutoFit/>
+          </a:bodyPr>
+          <a:lstStyle/>
+          <a:p>
+            <a:pPr>
+              <a:spcAft>
+                <a:spcPts val="600"/>
+              </a:spcAft>
+              <a:defRPr sz="1800" b="1">
+                <a:solidFill>
+                  <a:srgbClr val="FFFFFF"/>
+                </a:solidFill>
+              </a:defRPr>
+            </a:pPr>
+            <a:r>
+              <a:t>Agent Sessions View — Un seul endroit pour tout gérer</a:t>
+            </a:r>
+          </a:p>
+        </p:txBody>
+      </p:sp>
+      <p:sp>
+        <p:nvSpPr>
+          <p:cNvPr id="4" name="TextBox 3"/>
+          <p:cNvSpPr txBox="1"/>
+          <p:nvPr/>
+        </p:nvSpPr>
+        <p:spPr>
+          <a:xfrm>
+            <a:off x="457200" y="1828800"/>
+            <a:ext cx="8229600" cy="4572000"/>
+          </a:xfrm>
+          <a:prstGeom prst="rect">
+            <a:avLst/>
+          </a:prstGeom>
+          <a:noFill/>
+        </p:spPr>
+        <p:txBody>
+          <a:bodyPr wrap="square">
+            <a:spAutoFit/>
+          </a:bodyPr>
+          <a:lstStyle/>
+          <a:p>
+            <a:pPr>
+              <a:spcAft>
+                <a:spcPts val="600"/>
+              </a:spcAft>
+              <a:defRPr sz="1300" b="0">
+                <a:solidFill>
+                  <a:srgbClr val="A0FFA0"/>
+                </a:solidFill>
+              </a:defRPr>
+            </a:pPr>
+            <a:r>
+              <a:t>┌─────────────────────────────────────────┐</a:t>
+            </a:r>
+          </a:p>
+          <a:p>
+            <a:pPr>
+              <a:spcAft>
+                <a:spcPts val="600"/>
+              </a:spcAft>
+              <a:defRPr sz="1300" b="0">
+                <a:solidFill>
+                  <a:srgbClr val="A0FFA0"/>
+                </a:solidFill>
+              </a:defRPr>
+            </a:pPr>
+            <a:r>
+              <a:t>│  🟢 Local — Copilot / Claude (Sonnet)   │  ← Interactif</a:t>
+            </a:r>
+          </a:p>
+          <a:p>
+            <a:pPr>
+              <a:spcAft>
+                <a:spcPts val="600"/>
+              </a:spcAft>
+              <a:defRPr sz="1300" b="0">
+                <a:solidFill>
+                  <a:srgbClr val="A0FFA0"/>
+                </a:solidFill>
+              </a:defRPr>
+            </a:pPr>
+            <a:r>
+              <a:t>│  🟡 Background — Claude (Opus)          │  ← Async, worktree isolé</a:t>
+            </a:r>
+          </a:p>
+          <a:p>
+            <a:pPr>
+              <a:spcAft>
+                <a:spcPts val="600"/>
+              </a:spcAft>
+              <a:defRPr sz="1300" b="0">
+                <a:solidFill>
+                  <a:srgbClr val="A0FFA0"/>
+                </a:solidFill>
+              </a:defRPr>
+            </a:pPr>
+            <a:r>
+              <a:t>│  🔵 Cloud — Codex / Claude              │  ← Remote, crée des PRs</a:t>
+            </a:r>
+          </a:p>
+          <a:p>
+            <a:pPr>
+              <a:spcAft>
+                <a:spcPts val="600"/>
+              </a:spcAft>
+              <a:defRPr sz="1300" b="0">
+                <a:solidFill>
+                  <a:srgbClr val="A0FFA0"/>
+                </a:solidFill>
+              </a:defRPr>
+            </a:pPr>
+            <a:r>
+              <a:t>│     └── Subagent: Research              │</a:t>
+            </a:r>
+          </a:p>
+          <a:p>
+            <a:pPr>
+              <a:spcAft>
+                <a:spcPts val="600"/>
+              </a:spcAft>
+              <a:defRPr sz="1300" b="0">
+                <a:solidFill>
+                  <a:srgbClr val="A0FFA0"/>
+                </a:solidFill>
+              </a:defRPr>
+            </a:pPr>
+            <a:r>
+              <a:t>│     └── Subagent: Security              │  ← Parallèle</a:t>
+            </a:r>
+          </a:p>
+          <a:p>
+            <a:pPr>
+              <a:spcAft>
+                <a:spcPts val="600"/>
+              </a:spcAft>
+              <a:defRPr sz="1300" b="0">
+                <a:solidFill>
+                  <a:srgbClr val="A0FFA0"/>
+                </a:solidFill>
+              </a:defRPr>
+            </a:pPr>
+            <a:r>
+              <a:t>└─────────────────────────────────────────┘</a:t>
+            </a:r>
+          </a:p>
+        </p:txBody>
+      </p:sp>
+      <p:sp>
+        <p:nvSpPr>
+          <p:cNvPr id="5" name="TextBox 4"/>
+          <p:cNvSpPr txBox="1"/>
+          <p:nvPr/>
+        </p:nvSpPr>
+        <p:spPr>
+          <a:xfrm>
+            <a:off x="457200" y="3657600"/>
+            <a:ext cx="8229600" cy="4572000"/>
+          </a:xfrm>
+          <a:prstGeom prst="rect">
+            <a:avLst/>
+          </a:prstGeom>
+          <a:noFill/>
+        </p:spPr>
+        <p:txBody>
+          <a:bodyPr wrap="square">
+            <a:spAutoFit/>
+          </a:bodyPr>
+          <a:lstStyle/>
+          <a:p>
+            <a:pPr>
+              <a:spcAft>
+                <a:spcPts val="600"/>
+              </a:spcAft>
+              <a:defRPr sz="1400" b="0">
+                <a:solidFill>
+                  <a:srgbClr val="FFFFFF"/>
+                </a:solidFill>
+              </a:defRPr>
+            </a:pPr>
+            <a:r>
+              <a:t>Local → Vous pilotez, itération rapide</a:t>
+            </a:r>
+          </a:p>
+          <a:p>
+            <a:pPr>
+              <a:spcAft>
+                <a:spcPts val="600"/>
+              </a:spcAft>
+              <a:defRPr sz="1400" b="0">
+                <a:solidFill>
+                  <a:srgbClr val="FFFFFF"/>
+                </a:solidFill>
+              </a:defRPr>
+            </a:pPr>
+            <a:r>
+              <a:t>Background → Tâche définie, vous codez en parallèle</a:t>
+            </a:r>
+          </a:p>
+          <a:p>
+            <a:pPr>
+              <a:spcAft>
+                <a:spcPts val="600"/>
+              </a:spcAft>
+              <a:defRPr sz="1400" b="0">
+                <a:solidFill>
+                  <a:srgbClr val="FFFFFF"/>
+                </a:solidFill>
+              </a:defRPr>
+            </a:pPr>
+            <a:r>
+              <a:t>Cloud → Feature complète, résultat en PR</a:t>
+            </a:r>
+          </a:p>
+          <a:p>
+            <a:pPr>
+              <a:spcAft>
+                <a:spcPts val="600"/>
+              </a:spcAft>
+              <a:defRPr sz="1400" b="0">
+                <a:solidFill>
+                  <a:srgbClr val="FFFFFF"/>
+                </a:solidFill>
+              </a:defRPr>
+            </a:pPr>
+          </a:p>
+          <a:p>
+            <a:pPr>
+              <a:spcAft>
+                <a:spcPts val="600"/>
+              </a:spcAft>
+              <a:defRPr sz="1400" b="0">
+                <a:solidFill>
+                  <a:srgbClr val="FFFFFF"/>
+                </a:solidFill>
+              </a:defRPr>
+            </a:pPr>
+            <a:r>
+              <a:t>⚡ Subagents parallèles : contexte isolé, seul le résultat remonte</a:t>
+            </a:r>
+          </a:p>
+          <a:p>
+            <a:pPr>
+              <a:spcAft>
+                <a:spcPts val="600"/>
+              </a:spcAft>
+              <a:defRPr sz="1400" b="0">
+                <a:solidFill>
+                  <a:srgbClr val="FFFFFF"/>
+                </a:solidFill>
+              </a:defRPr>
+            </a:pPr>
+            <a:r>
+              <a:t>🔗 Handoffs : workflows automatiques (Code → Review → Fix)</a:t>
+            </a:r>
+          </a:p>
+          <a:p>
+            <a:pPr>
+              <a:spcAft>
+                <a:spcPts val="600"/>
+              </a:spcAft>
+              <a:defRPr sz="1400" b="0">
+                <a:solidFill>
+                  <a:srgbClr val="FFFFFF"/>
+                </a:solidFill>
+              </a:defRPr>
+            </a:pPr>
+            <a:r>
+              <a:t>🤖 Claude &amp; Codex natifs sous votre abonnement Copilot</a:t>
             </a:r>
           </a:p>
         </p:txBody>
@@ -8951,7 +8849,7 @@
         <p:spPr>
           <a:xfrm>
             <a:off x="457200" y="274320"/>
-            <a:ext cx="10972800" cy="731520"/>
+            <a:ext cx="8229600" cy="914400"/>
           </a:xfrm>
           <a:prstGeom prst="rect">
             <a:avLst/>
@@ -8964,15 +8862,15 @@
           </a:bodyPr>
           <a:lstStyle/>
           <a:p>
-            <a:pPr algn="l">
-              <a:defRPr sz="3600" b="1">
-                <a:solidFill>
-                  <a:srgbClr val="E94560"/>
-                </a:solidFill>
-              </a:defRPr>
-            </a:pPr>
-            <a:r>
-              <a:t>📉 5 Strategies to Reduce Tokens</a:t>
+            <a:pPr>
+              <a:defRPr sz="2800" b="1">
+                <a:solidFill>
+                  <a:srgbClr val="FFFFFF"/>
+                </a:solidFill>
+              </a:defRPr>
+            </a:pPr>
+            <a:r>
+              <a:t>📉 6 Strategies to Reduce Tokens</a:t>
             </a:r>
           </a:p>
         </p:txBody>
@@ -8986,7 +8884,7 @@
         <p:spPr>
           <a:xfrm>
             <a:off x="457200" y="1280160"/>
-            <a:ext cx="548640" cy="457200"/>
+            <a:ext cx="8229600" cy="4572000"/>
           </a:xfrm>
           <a:prstGeom prst="rect">
             <a:avLst/>
@@ -8999,15 +8897,153 @@
           </a:bodyPr>
           <a:lstStyle/>
           <a:p>
-            <a:pPr algn="ctr">
-              <a:defRPr sz="2200" b="0">
+            <a:pPr>
+              <a:spcAft>
+                <a:spcPts val="600"/>
+              </a:spcAft>
+              <a:defRPr sz="1500" b="0">
                 <a:solidFill>
                   <a:srgbClr val="FFFFFF"/>
                 </a:solidFill>
               </a:defRPr>
             </a:pPr>
             <a:r>
-              <a:t>🎯</a:t>
+              <a:t>🎯  Precise prompts — Fewer round-trips = fewer tokens</a:t>
+            </a:r>
+          </a:p>
+          <a:p>
+            <a:pPr>
+              <a:spcAft>
+                <a:spcPts val="600"/>
+              </a:spcAft>
+              <a:defRPr sz="1500" b="0">
+                <a:solidFill>
+                  <a:srgbClr val="FFFFFF"/>
+                </a:solidFill>
+              </a:defRPr>
+            </a:pPr>
+          </a:p>
+          <a:p>
+            <a:pPr>
+              <a:spcAft>
+                <a:spcPts val="600"/>
+              </a:spcAft>
+              <a:defRPr sz="1500" b="0">
+                <a:solidFill>
+                  <a:srgbClr val="FFFFFF"/>
+                </a:solidFill>
+              </a:defRPr>
+            </a:pPr>
+            <a:r>
+              <a:t>📁  copilot-instructions.md — Context loaded once, never repeated</a:t>
+            </a:r>
+          </a:p>
+          <a:p>
+            <a:pPr>
+              <a:spcAft>
+                <a:spcPts val="600"/>
+              </a:spcAft>
+              <a:defRPr sz="1500" b="0">
+                <a:solidFill>
+                  <a:srgbClr val="FFFFFF"/>
+                </a:solidFill>
+              </a:defRPr>
+            </a:pPr>
+          </a:p>
+          <a:p>
+            <a:pPr>
+              <a:spcAft>
+                <a:spcPts val="600"/>
+              </a:spcAft>
+              <a:defRPr sz="1500" b="0">
+                <a:solidFill>
+                  <a:srgbClr val="FFFFFF"/>
+                </a:solidFill>
+              </a:defRPr>
+            </a:pPr>
+            <a:r>
+              <a:t>🔀  Reusable Skills &amp; Prompts — Stop reformulating</a:t>
+            </a:r>
+          </a:p>
+          <a:p>
+            <a:pPr>
+              <a:spcAft>
+                <a:spcPts val="600"/>
+              </a:spcAft>
+              <a:defRPr sz="1500" b="0">
+                <a:solidFill>
+                  <a:srgbClr val="FFFFFF"/>
+                </a:solidFill>
+              </a:defRPr>
+            </a:pPr>
+          </a:p>
+          <a:p>
+            <a:pPr>
+              <a:spcAft>
+                <a:spcPts val="600"/>
+              </a:spcAft>
+              <a:defRPr sz="1500" b="0">
+                <a:solidFill>
+                  <a:srgbClr val="FFFFFF"/>
+                </a:solidFill>
+              </a:defRPr>
+            </a:pPr>
+            <a:r>
+              <a:t>🧹  Fresh conversations — New chat when context is polluted</a:t>
+            </a:r>
+          </a:p>
+          <a:p>
+            <a:pPr>
+              <a:spcAft>
+                <a:spcPts val="600"/>
+              </a:spcAft>
+              <a:defRPr sz="1500" b="0">
+                <a:solidFill>
+                  <a:srgbClr val="FFFFFF"/>
+                </a:solidFill>
+              </a:defRPr>
+            </a:pPr>
+          </a:p>
+          <a:p>
+            <a:pPr>
+              <a:spcAft>
+                <a:spcPts val="600"/>
+              </a:spcAft>
+              <a:defRPr sz="1500" b="0">
+                <a:solidFill>
+                  <a:srgbClr val="FFFFFF"/>
+                </a:solidFill>
+              </a:defRPr>
+            </a:pPr>
+            <a:r>
+              <a:t>📏  Right model = right cost — Haiku for simple, Sonnet for the rest</a:t>
+            </a:r>
+          </a:p>
+          <a:p>
+            <a:pPr>
+              <a:spcAft>
+                <a:spcPts val="600"/>
+              </a:spcAft>
+              <a:defRPr sz="1500" b="0">
+                <a:solidFill>
+                  <a:srgbClr val="FFFFFF"/>
+                </a:solidFill>
+              </a:defRPr>
+            </a:pPr>
+          </a:p>
+          <a:p>
+            <a:pPr>
+              <a:spcAft>
+                <a:spcPts val="600"/>
+              </a:spcAft>
+              <a:defRPr sz="1500" b="0">
+                <a:solidFill>
+                  <a:srgbClr val="FFFFFF"/>
+                </a:solidFill>
+              </a:defRPr>
+            </a:pPr>
+            <a:r>
+              <a:t>🦴  Caveman Mode — 50-70% fewer output tokens, same code quality</a:t>
             </a:r>
           </a:p>
         </p:txBody>
@@ -9020,8 +9056,8 @@
         </p:nvSpPr>
         <p:spPr>
           <a:xfrm>
-            <a:off x="1097280" y="1280160"/>
-            <a:ext cx="4114800" cy="457200"/>
+            <a:off x="457200" y="5029200"/>
+            <a:ext cx="8229600" cy="4572000"/>
           </a:xfrm>
           <a:prstGeom prst="rect">
             <a:avLst/>
@@ -9034,524 +9070,33 @@
           </a:bodyPr>
           <a:lstStyle/>
           <a:p>
-            <a:pPr algn="l">
-              <a:defRPr sz="1600" b="1">
-                <a:solidFill>
-                  <a:srgbClr val="FFFFFF"/>
-                </a:solidFill>
-              </a:defRPr>
-            </a:pPr>
-            <a:r>
-              <a:t>Precise prompts from the start</a:t>
-            </a:r>
-          </a:p>
-        </p:txBody>
-      </p:sp>
-      <p:sp>
-        <p:nvSpPr>
-          <p:cNvPr id="5" name="TextBox 4"/>
-          <p:cNvSpPr txBox="1"/>
-          <p:nvPr/>
-        </p:nvSpPr>
-        <p:spPr>
-          <a:xfrm>
-            <a:off x="1097280" y="1600200"/>
-            <a:ext cx="9144000" cy="365760"/>
-          </a:xfrm>
-          <a:prstGeom prst="rect">
-            <a:avLst/>
-          </a:prstGeom>
-          <a:noFill/>
-        </p:spPr>
-        <p:txBody>
-          <a:bodyPr wrap="square">
-            <a:spAutoFit/>
-          </a:bodyPr>
-          <a:lstStyle/>
-          <a:p>
-            <a:pPr algn="l">
+            <a:pPr>
+              <a:spcAft>
+                <a:spcPts val="600"/>
+              </a:spcAft>
               <a:defRPr sz="1300" b="0">
                 <a:solidFill>
-                  <a:srgbClr val="A8B2D1"/>
-                </a:solidFill>
-              </a:defRPr>
-            </a:pPr>
-            <a:r>
-              <a:t>Fewer round-trips = fewer tokens consumed</a:t>
-            </a:r>
-          </a:p>
-        </p:txBody>
-      </p:sp>
-      <p:sp>
-        <p:nvSpPr>
-          <p:cNvPr id="6" name="TextBox 5"/>
-          <p:cNvSpPr txBox="1"/>
-          <p:nvPr/>
-        </p:nvSpPr>
-        <p:spPr>
-          <a:xfrm>
-            <a:off x="457200" y="2148839"/>
-            <a:ext cx="548640" cy="457200"/>
-          </a:xfrm>
-          <a:prstGeom prst="rect">
-            <a:avLst/>
-          </a:prstGeom>
-          <a:noFill/>
-        </p:spPr>
-        <p:txBody>
-          <a:bodyPr wrap="square">
-            <a:spAutoFit/>
-          </a:bodyPr>
-          <a:lstStyle/>
-          <a:p>
-            <a:pPr algn="ctr">
-              <a:defRPr sz="2200" b="0">
-                <a:solidFill>
-                  <a:srgbClr val="FFFFFF"/>
-                </a:solidFill>
-              </a:defRPr>
-            </a:pPr>
-            <a:r>
-              <a:t>📁</a:t>
-            </a:r>
-          </a:p>
-        </p:txBody>
-      </p:sp>
-      <p:sp>
-        <p:nvSpPr>
-          <p:cNvPr id="7" name="TextBox 6"/>
-          <p:cNvSpPr txBox="1"/>
-          <p:nvPr/>
-        </p:nvSpPr>
-        <p:spPr>
-          <a:xfrm>
-            <a:off x="1097280" y="2148839"/>
-            <a:ext cx="4114800" cy="457200"/>
-          </a:xfrm>
-          <a:prstGeom prst="rect">
-            <a:avLst/>
-          </a:prstGeom>
-          <a:noFill/>
-        </p:spPr>
-        <p:txBody>
-          <a:bodyPr wrap="square">
-            <a:spAutoFit/>
-          </a:bodyPr>
-          <a:lstStyle/>
-          <a:p>
-            <a:pPr algn="l">
-              <a:defRPr sz="1600" b="1">
-                <a:solidFill>
-                  <a:srgbClr val="FFFFFF"/>
-                </a:solidFill>
-              </a:defRPr>
-            </a:pPr>
-            <a:r>
-              <a:t>copilot-instructions.md</a:t>
-            </a:r>
-          </a:p>
-        </p:txBody>
-      </p:sp>
-      <p:sp>
-        <p:nvSpPr>
-          <p:cNvPr id="8" name="TextBox 7"/>
-          <p:cNvSpPr txBox="1"/>
-          <p:nvPr/>
-        </p:nvSpPr>
-        <p:spPr>
-          <a:xfrm>
-            <a:off x="1097280" y="2468879"/>
-            <a:ext cx="9144000" cy="365760"/>
-          </a:xfrm>
-          <a:prstGeom prst="rect">
-            <a:avLst/>
-          </a:prstGeom>
-          <a:noFill/>
-        </p:spPr>
-        <p:txBody>
-          <a:bodyPr wrap="square">
-            <a:spAutoFit/>
-          </a:bodyPr>
-          <a:lstStyle/>
-          <a:p>
-            <a:pPr algn="l">
+                  <a:srgbClr val="A0FFA0"/>
+                </a:solidFill>
+              </a:defRPr>
+            </a:pPr>
+            <a:r>
+              <a:t>✅ These practices reduce costs AND improve quality — less noise = better answers</a:t>
+            </a:r>
+          </a:p>
+          <a:p>
+            <a:pPr>
+              <a:spcAft>
+                <a:spcPts val="600"/>
+              </a:spcAft>
               <a:defRPr sz="1300" b="0">
                 <a:solidFill>
-                  <a:srgbClr val="A8B2D1"/>
-                </a:solidFill>
-              </a:defRPr>
-            </a:pPr>
-            <a:r>
-              <a:t>Context loaded once, not repeated every message</a:t>
-            </a:r>
-          </a:p>
-        </p:txBody>
-      </p:sp>
-      <p:sp>
-        <p:nvSpPr>
-          <p:cNvPr id="9" name="TextBox 8"/>
-          <p:cNvSpPr txBox="1"/>
-          <p:nvPr/>
-        </p:nvSpPr>
-        <p:spPr>
-          <a:xfrm>
-            <a:off x="457200" y="3017520"/>
-            <a:ext cx="548640" cy="457200"/>
-          </a:xfrm>
-          <a:prstGeom prst="rect">
-            <a:avLst/>
-          </a:prstGeom>
-          <a:noFill/>
-        </p:spPr>
-        <p:txBody>
-          <a:bodyPr wrap="square">
-            <a:spAutoFit/>
-          </a:bodyPr>
-          <a:lstStyle/>
-          <a:p>
-            <a:pPr algn="ctr">
-              <a:defRPr sz="2200" b="0">
-                <a:solidFill>
-                  <a:srgbClr val="FFFFFF"/>
-                </a:solidFill>
-              </a:defRPr>
-            </a:pPr>
-            <a:r>
-              <a:t>🔀</a:t>
-            </a:r>
-          </a:p>
-        </p:txBody>
-      </p:sp>
-      <p:sp>
-        <p:nvSpPr>
-          <p:cNvPr id="10" name="TextBox 9"/>
-          <p:cNvSpPr txBox="1"/>
-          <p:nvPr/>
-        </p:nvSpPr>
-        <p:spPr>
-          <a:xfrm>
-            <a:off x="1097280" y="3017520"/>
-            <a:ext cx="4114800" cy="457200"/>
-          </a:xfrm>
-          <a:prstGeom prst="rect">
-            <a:avLst/>
-          </a:prstGeom>
-          <a:noFill/>
-        </p:spPr>
-        <p:txBody>
-          <a:bodyPr wrap="square">
-            <a:spAutoFit/>
-          </a:bodyPr>
-          <a:lstStyle/>
-          <a:p>
-            <a:pPr algn="l">
-              <a:defRPr sz="1600" b="1">
-                <a:solidFill>
-                  <a:srgbClr val="FFFFFF"/>
-                </a:solidFill>
-              </a:defRPr>
-            </a:pPr>
-            <a:r>
-              <a:t>Reusable prompt templates</a:t>
-            </a:r>
-          </a:p>
-        </p:txBody>
-      </p:sp>
-      <p:sp>
-        <p:nvSpPr>
-          <p:cNvPr id="11" name="TextBox 10"/>
-          <p:cNvSpPr txBox="1"/>
-          <p:nvPr/>
-        </p:nvSpPr>
-        <p:spPr>
-          <a:xfrm>
-            <a:off x="1097280" y="3337560"/>
-            <a:ext cx="9144000" cy="365760"/>
-          </a:xfrm>
-          <a:prstGeom prst="rect">
-            <a:avLst/>
-          </a:prstGeom>
-          <a:noFill/>
-        </p:spPr>
-        <p:txBody>
-          <a:bodyPr wrap="square">
-            <a:spAutoFit/>
-          </a:bodyPr>
-          <a:lstStyle/>
-          <a:p>
-            <a:pPr algn="l">
-              <a:defRPr sz="1300" b="0">
-                <a:solidFill>
-                  <a:srgbClr val="A8B2D1"/>
-                </a:solidFill>
-              </a:defRPr>
-            </a:pPr>
-            <a:r>
-              <a:t>Stop reformulating the same requests</a:t>
-            </a:r>
-          </a:p>
-        </p:txBody>
-      </p:sp>
-      <p:sp>
-        <p:nvSpPr>
-          <p:cNvPr id="12" name="TextBox 11"/>
-          <p:cNvSpPr txBox="1"/>
-          <p:nvPr/>
-        </p:nvSpPr>
-        <p:spPr>
-          <a:xfrm>
-            <a:off x="457200" y="3886200"/>
-            <a:ext cx="548640" cy="457200"/>
-          </a:xfrm>
-          <a:prstGeom prst="rect">
-            <a:avLst/>
-          </a:prstGeom>
-          <a:noFill/>
-        </p:spPr>
-        <p:txBody>
-          <a:bodyPr wrap="square">
-            <a:spAutoFit/>
-          </a:bodyPr>
-          <a:lstStyle/>
-          <a:p>
-            <a:pPr algn="ctr">
-              <a:defRPr sz="2200" b="0">
-                <a:solidFill>
-                  <a:srgbClr val="FFFFFF"/>
-                </a:solidFill>
-              </a:defRPr>
-            </a:pPr>
-            <a:r>
-              <a:t>🧹</a:t>
-            </a:r>
-          </a:p>
-        </p:txBody>
-      </p:sp>
-      <p:sp>
-        <p:nvSpPr>
-          <p:cNvPr id="13" name="TextBox 12"/>
-          <p:cNvSpPr txBox="1"/>
-          <p:nvPr/>
-        </p:nvSpPr>
-        <p:spPr>
-          <a:xfrm>
-            <a:off x="1097280" y="3886200"/>
-            <a:ext cx="4114800" cy="457200"/>
-          </a:xfrm>
-          <a:prstGeom prst="rect">
-            <a:avLst/>
-          </a:prstGeom>
-          <a:noFill/>
-        </p:spPr>
-        <p:txBody>
-          <a:bodyPr wrap="square">
-            <a:spAutoFit/>
-          </a:bodyPr>
-          <a:lstStyle/>
-          <a:p>
-            <a:pPr algn="l">
-              <a:defRPr sz="1600" b="1">
-                <a:solidFill>
-                  <a:srgbClr val="FFFFFF"/>
-                </a:solidFill>
-              </a:defRPr>
-            </a:pPr>
-            <a:r>
-              <a:t>Fresh conversations</a:t>
-            </a:r>
-          </a:p>
-        </p:txBody>
-      </p:sp>
-      <p:sp>
-        <p:nvSpPr>
-          <p:cNvPr id="14" name="TextBox 13"/>
-          <p:cNvSpPr txBox="1"/>
-          <p:nvPr/>
-        </p:nvSpPr>
-        <p:spPr>
-          <a:xfrm>
-            <a:off x="1097280" y="4206240"/>
-            <a:ext cx="9144000" cy="365760"/>
-          </a:xfrm>
-          <a:prstGeom prst="rect">
-            <a:avLst/>
-          </a:prstGeom>
-          <a:noFill/>
-        </p:spPr>
-        <p:txBody>
-          <a:bodyPr wrap="square">
-            <a:spAutoFit/>
-          </a:bodyPr>
-          <a:lstStyle/>
-          <a:p>
-            <a:pPr algn="l">
-              <a:defRPr sz="1300" b="0">
-                <a:solidFill>
-                  <a:srgbClr val="A8B2D1"/>
-                </a:solidFill>
-              </a:defRPr>
-            </a:pPr>
-            <a:r>
-              <a:t>Start new when context is polluted or too long</a:t>
-            </a:r>
-          </a:p>
-        </p:txBody>
-      </p:sp>
-      <p:sp>
-        <p:nvSpPr>
-          <p:cNvPr id="15" name="TextBox 14"/>
-          <p:cNvSpPr txBox="1"/>
-          <p:nvPr/>
-        </p:nvSpPr>
-        <p:spPr>
-          <a:xfrm>
-            <a:off x="457200" y="4754880"/>
-            <a:ext cx="548640" cy="457200"/>
-          </a:xfrm>
-          <a:prstGeom prst="rect">
-            <a:avLst/>
-          </a:prstGeom>
-          <a:noFill/>
-        </p:spPr>
-        <p:txBody>
-          <a:bodyPr wrap="square">
-            <a:spAutoFit/>
-          </a:bodyPr>
-          <a:lstStyle/>
-          <a:p>
-            <a:pPr algn="ctr">
-              <a:defRPr sz="2200" b="0">
-                <a:solidFill>
-                  <a:srgbClr val="FFFFFF"/>
-                </a:solidFill>
-              </a:defRPr>
-            </a:pPr>
-            <a:r>
-              <a:t>📏</a:t>
-            </a:r>
-          </a:p>
-        </p:txBody>
-      </p:sp>
-      <p:sp>
-        <p:nvSpPr>
-          <p:cNvPr id="16" name="TextBox 15"/>
-          <p:cNvSpPr txBox="1"/>
-          <p:nvPr/>
-        </p:nvSpPr>
-        <p:spPr>
-          <a:xfrm>
-            <a:off x="1097280" y="4754880"/>
-            <a:ext cx="4114800" cy="457200"/>
-          </a:xfrm>
-          <a:prstGeom prst="rect">
-            <a:avLst/>
-          </a:prstGeom>
-          <a:noFill/>
-        </p:spPr>
-        <p:txBody>
-          <a:bodyPr wrap="square">
-            <a:spAutoFit/>
-          </a:bodyPr>
-          <a:lstStyle/>
-          <a:p>
-            <a:pPr algn="l">
-              <a:defRPr sz="1600" b="1">
-                <a:solidFill>
-                  <a:srgbClr val="FFFFFF"/>
-                </a:solidFill>
-              </a:defRPr>
-            </a:pPr>
-            <a:r>
-              <a:t>Right model = right cost</a:t>
-            </a:r>
-          </a:p>
-        </p:txBody>
-      </p:sp>
-      <p:sp>
-        <p:nvSpPr>
-          <p:cNvPr id="17" name="TextBox 16"/>
-          <p:cNvSpPr txBox="1"/>
-          <p:nvPr/>
-        </p:nvSpPr>
-        <p:spPr>
-          <a:xfrm>
-            <a:off x="1097280" y="5074920"/>
-            <a:ext cx="9144000" cy="365760"/>
-          </a:xfrm>
-          <a:prstGeom prst="rect">
-            <a:avLst/>
-          </a:prstGeom>
-          <a:noFill/>
-        </p:spPr>
-        <p:txBody>
-          <a:bodyPr wrap="square">
-            <a:spAutoFit/>
-          </a:bodyPr>
-          <a:lstStyle/>
-          <a:p>
-            <a:pPr algn="l">
-              <a:defRPr sz="1300" b="0">
-                <a:solidFill>
-                  <a:srgbClr val="A8B2D1"/>
-                </a:solidFill>
-              </a:defRPr>
-            </a:pPr>
-            <a:r>
-              <a:t>Haiku for simple tasks, Sonnet for the rest</a:t>
-            </a:r>
-          </a:p>
-        </p:txBody>
-      </p:sp>
-      <p:sp>
-        <p:nvSpPr>
-          <p:cNvPr id="18" name="Rounded Rectangle 17"/>
-          <p:cNvSpPr/>
-          <p:nvPr/>
-        </p:nvSpPr>
-        <p:spPr>
-          <a:xfrm>
-            <a:off x="457200" y="5669280"/>
-            <a:ext cx="10972800" cy="731520"/>
-          </a:xfrm>
-          <a:prstGeom prst="roundRect">
-            <a:avLst/>
-          </a:prstGeom>
-          <a:solidFill>
-            <a:srgbClr val="12251A"/>
-          </a:solidFill>
-          <a:ln w="19050">
-            <a:solidFill>
-              <a:srgbClr val="2ED573"/>
-            </a:solidFill>
-          </a:ln>
-        </p:spPr>
-        <p:style>
-          <a:lnRef idx="1">
-            <a:schemeClr val="accent1"/>
-          </a:lnRef>
-          <a:fillRef idx="3">
-            <a:schemeClr val="accent1"/>
-          </a:fillRef>
-          <a:effectRef idx="2">
-            <a:schemeClr val="accent1"/>
-          </a:effectRef>
-          <a:fontRef idx="minor">
-            <a:schemeClr val="lt1"/>
-          </a:fontRef>
-        </p:style>
-        <p:txBody>
-          <a:bodyPr rtlCol="0" anchor="ctr" wrap="square"/>
-          <a:lstStyle/>
-          <a:p>
-            <a:pPr algn="ctr">
-              <a:defRPr sz="1400">
-                <a:solidFill>
-                  <a:srgbClr val="2ED573"/>
-                </a:solidFill>
-              </a:defRPr>
-            </a:pPr>
-            <a:r>
-              <a:t>✅ These practices reduce costs AND improve output quality — less noise = better answers</a:t>
+                  <a:srgbClr val="A0FFA0"/>
+                </a:solidFill>
+              </a:defRPr>
+            </a:pPr>
+            <a:r>
+              <a:t>💰 Output tokens cost 3-4x more than input → Caveman = biggest ROI</a:t>
             </a:r>
           </a:p>
         </p:txBody>
@@ -10121,7 +9666,7 @@
         <p:spPr>
           <a:xfrm>
             <a:off x="457200" y="274320"/>
-            <a:ext cx="10972800" cy="731520"/>
+            <a:ext cx="8229600" cy="914400"/>
           </a:xfrm>
           <a:prstGeom prst="rect">
             <a:avLst/>
@@ -10134,10 +9679,10 @@
           </a:bodyPr>
           <a:lstStyle/>
           <a:p>
-            <a:pPr algn="l">
-              <a:defRPr sz="3600" b="1">
-                <a:solidFill>
-                  <a:srgbClr val="E94560"/>
+            <a:pPr>
+              <a:defRPr sz="2800" b="1">
+                <a:solidFill>
+                  <a:srgbClr val="FFFFFF"/>
                 </a:solidFill>
               </a:defRPr>
             </a:pPr>
@@ -10149,314 +9694,276 @@
       </p:sp>
       <p:sp>
         <p:nvSpPr>
-          <p:cNvPr id="3" name="Rounded Rectangle 2"/>
-          <p:cNvSpPr/>
-          <p:nvPr/>
-        </p:nvSpPr>
-        <p:spPr>
-          <a:xfrm>
-            <a:off x="914400" y="1828800"/>
-            <a:ext cx="2286000" cy="2011680"/>
-          </a:xfrm>
-          <a:prstGeom prst="roundRect">
-            <a:avLst/>
-          </a:prstGeom>
-          <a:solidFill>
-            <a:srgbClr val="16213E"/>
-          </a:solidFill>
-          <a:ln w="19050">
-            <a:solidFill>
-              <a:srgbClr val="2ED573"/>
-            </a:solidFill>
-          </a:ln>
-        </p:spPr>
-        <p:style>
-          <a:lnRef idx="1">
-            <a:schemeClr val="accent1"/>
-          </a:lnRef>
-          <a:fillRef idx="3">
-            <a:schemeClr val="accent1"/>
-          </a:fillRef>
-          <a:effectRef idx="2">
-            <a:schemeClr val="accent1"/>
-          </a:effectRef>
-          <a:fontRef idx="minor">
-            <a:schemeClr val="lt1"/>
-          </a:fontRef>
-        </p:style>
-        <p:txBody>
-          <a:bodyPr rtlCol="0" anchor="ctr" wrap="square"/>
-          <a:lstStyle/>
-          <a:p>
-            <a:pPr algn="ctr">
-              <a:defRPr sz="1300">
-                <a:solidFill>
-                  <a:srgbClr val="2ED573"/>
-                </a:solidFill>
-              </a:defRPr>
-            </a:pPr>
-            <a:r>
-              <a:t>✓</a:t>
-            </a:r>
-            <a:br/>
-            <a:br/>
-            <a:r>
-              <a:t>Completion</a:t>
-            </a:r>
-            <a:br/>
-            <a:r>
-              <a:t>Code suggestions</a:t>
-            </a:r>
-          </a:p>
-        </p:txBody>
-      </p:sp>
-      <p:sp>
-        <p:nvSpPr>
-          <p:cNvPr id="4" name="Rounded Rectangle 3"/>
-          <p:cNvSpPr/>
-          <p:nvPr/>
-        </p:nvSpPr>
-        <p:spPr>
-          <a:xfrm>
-            <a:off x="3657600" y="1828800"/>
-            <a:ext cx="2286000" cy="2011680"/>
-          </a:xfrm>
-          <a:prstGeom prst="roundRect">
-            <a:avLst/>
-          </a:prstGeom>
-          <a:solidFill>
-            <a:srgbClr val="16213E"/>
-          </a:solidFill>
-          <a:ln w="19050">
-            <a:solidFill>
-              <a:srgbClr val="2ED573"/>
-            </a:solidFill>
-          </a:ln>
-        </p:spPr>
-        <p:style>
-          <a:lnRef idx="1">
-            <a:schemeClr val="accent1"/>
-          </a:lnRef>
-          <a:fillRef idx="3">
-            <a:schemeClr val="accent1"/>
-          </a:fillRef>
-          <a:effectRef idx="2">
-            <a:schemeClr val="accent1"/>
-          </a:effectRef>
-          <a:fontRef idx="minor">
-            <a:schemeClr val="lt1"/>
-          </a:fontRef>
-        </p:style>
-        <p:txBody>
-          <a:bodyPr rtlCol="0" anchor="ctr" wrap="square"/>
-          <a:lstStyle/>
-          <a:p>
-            <a:pPr algn="ctr">
-              <a:defRPr sz="1300">
-                <a:solidFill>
-                  <a:srgbClr val="2ED573"/>
-                </a:solidFill>
-              </a:defRPr>
-            </a:pPr>
-            <a:r>
-              <a:t>✓</a:t>
-            </a:r>
-            <a:br/>
-            <a:br/>
-            <a:r>
-              <a:t>Chat &amp; Agent</a:t>
-            </a:r>
-            <a:br/>
-            <a:r>
-              <a:t>Conversational AI</a:t>
-            </a:r>
-          </a:p>
-        </p:txBody>
-      </p:sp>
-      <p:sp>
-        <p:nvSpPr>
-          <p:cNvPr id="5" name="Rounded Rectangle 4"/>
-          <p:cNvSpPr/>
-          <p:nvPr/>
-        </p:nvSpPr>
-        <p:spPr>
-          <a:xfrm>
-            <a:off x="6400800" y="1828800"/>
-            <a:ext cx="2286000" cy="2011680"/>
-          </a:xfrm>
-          <a:prstGeom prst="roundRect">
-            <a:avLst/>
-          </a:prstGeom>
-          <a:solidFill>
-            <a:srgbClr val="16213E"/>
-          </a:solidFill>
-          <a:ln w="19050">
-            <a:solidFill>
-              <a:srgbClr val="4FACFE"/>
-            </a:solidFill>
-          </a:ln>
-        </p:spPr>
-        <p:style>
-          <a:lnRef idx="1">
-            <a:schemeClr val="accent1"/>
-          </a:lnRef>
-          <a:fillRef idx="3">
-            <a:schemeClr val="accent1"/>
-          </a:fillRef>
-          <a:effectRef idx="2">
-            <a:schemeClr val="accent1"/>
-          </a:effectRef>
-          <a:fontRef idx="minor">
-            <a:schemeClr val="lt1"/>
-          </a:fontRef>
-        </p:style>
-        <p:txBody>
-          <a:bodyPr rtlCol="0" anchor="ctr" wrap="square"/>
-          <a:lstStyle/>
-          <a:p>
-            <a:pPr algn="ctr">
-              <a:defRPr sz="1300">
-                <a:solidFill>
-                  <a:srgbClr val="4FACFE"/>
-                </a:solidFill>
-              </a:defRPr>
-            </a:pPr>
-            <a:r>
-              <a:t>→</a:t>
-            </a:r>
-            <a:br/>
-            <a:br/>
-            <a:r>
-              <a:t>Multi-Agent</a:t>
-            </a:r>
-            <a:br/>
-            <a:r>
-              <a:t>Orchestration</a:t>
-            </a:r>
-            <a:br/>
-            <a:r>
-              <a:t>WE ARE HERE</a:t>
-            </a:r>
-          </a:p>
-        </p:txBody>
-      </p:sp>
-      <p:sp>
-        <p:nvSpPr>
-          <p:cNvPr id="6" name="Rounded Rectangle 5"/>
-          <p:cNvSpPr/>
-          <p:nvPr/>
-        </p:nvSpPr>
-        <p:spPr>
-          <a:xfrm>
-            <a:off x="9144000" y="1828800"/>
-            <a:ext cx="2286000" cy="2011680"/>
-          </a:xfrm>
-          <a:prstGeom prst="roundRect">
-            <a:avLst/>
-          </a:prstGeom>
-          <a:solidFill>
-            <a:srgbClr val="16213E"/>
-          </a:solidFill>
-          <a:ln w="19050">
-            <a:solidFill>
-              <a:srgbClr val="E94560"/>
-            </a:solidFill>
-          </a:ln>
-        </p:spPr>
-        <p:style>
-          <a:lnRef idx="1">
-            <a:schemeClr val="accent1"/>
-          </a:lnRef>
-          <a:fillRef idx="3">
-            <a:schemeClr val="accent1"/>
-          </a:fillRef>
-          <a:effectRef idx="2">
-            <a:schemeClr val="accent1"/>
-          </a:effectRef>
-          <a:fontRef idx="minor">
-            <a:schemeClr val="lt1"/>
-          </a:fontRef>
-        </p:style>
-        <p:txBody>
-          <a:bodyPr rtlCol="0" anchor="ctr" wrap="square"/>
-          <a:lstStyle/>
-          <a:p>
-            <a:pPr algn="ctr">
-              <a:defRPr sz="1300">
-                <a:solidFill>
-                  <a:srgbClr val="E94560"/>
-                </a:solidFill>
-              </a:defRPr>
-            </a:pPr>
-            <a:r>
-              <a:t>⟶</a:t>
-            </a:r>
-            <a:br/>
-            <a:br/>
-            <a:r>
-              <a:t>Autonomous</a:t>
-            </a:r>
-            <a:br/>
-            <a:r>
-              <a:t>Full workflow agents</a:t>
-            </a:r>
-          </a:p>
-        </p:txBody>
-      </p:sp>
-      <p:sp>
-        <p:nvSpPr>
-          <p:cNvPr id="7" name="Rounded Rectangle 6"/>
-          <p:cNvSpPr/>
-          <p:nvPr/>
-        </p:nvSpPr>
-        <p:spPr>
-          <a:xfrm>
-            <a:off x="457200" y="4572000"/>
-            <a:ext cx="10972800" cy="1097280"/>
-          </a:xfrm>
-          <a:prstGeom prst="roundRect">
-            <a:avLst/>
-          </a:prstGeom>
-          <a:solidFill>
-            <a:srgbClr val="2A1A2E"/>
-          </a:solidFill>
-          <a:ln w="19050">
-            <a:solidFill>
-              <a:srgbClr val="E94560"/>
-            </a:solidFill>
-          </a:ln>
-        </p:spPr>
-        <p:style>
-          <a:lnRef idx="1">
-            <a:schemeClr val="accent1"/>
-          </a:lnRef>
-          <a:fillRef idx="3">
-            <a:schemeClr val="accent1"/>
-          </a:fillRef>
-          <a:effectRef idx="2">
-            <a:schemeClr val="accent1"/>
-          </a:effectRef>
-          <a:fontRef idx="minor">
-            <a:schemeClr val="lt1"/>
-          </a:fontRef>
-        </p:style>
-        <p:txBody>
-          <a:bodyPr rtlCol="0" anchor="ctr" wrap="square"/>
-          <a:lstStyle/>
-          <a:p>
-            <a:pPr algn="ctr">
-              <a:defRPr sz="1400">
+          <p:cNvPr id="3" name="TextBox 2"/>
+          <p:cNvSpPr txBox="1"/>
+          <p:nvPr/>
+        </p:nvSpPr>
+        <p:spPr>
+          <a:xfrm>
+            <a:off x="457200" y="1371600"/>
+            <a:ext cx="8229600" cy="4572000"/>
+          </a:xfrm>
+          <a:prstGeom prst="rect">
+            <a:avLst/>
+          </a:prstGeom>
+          <a:noFill/>
+        </p:spPr>
+        <p:txBody>
+          <a:bodyPr wrap="square">
+            <a:spAutoFit/>
+          </a:bodyPr>
+          <a:lstStyle/>
+          <a:p>
+            <a:pPr>
+              <a:spcAft>
+                <a:spcPts val="600"/>
+              </a:spcAft>
+              <a:defRPr sz="1400" b="0">
                 <a:solidFill>
                   <a:srgbClr val="FFFFFF"/>
                 </a:solidFill>
               </a:defRPr>
             </a:pPr>
             <a:r>
-              <a:t>🎯 Orange positioning: We're at the multi-agent stage.</a:t>
-            </a:r>
-            <a:br/>
-            <a:r>
-              <a:t>Industrializing NOW sets us up for autonomous workflows NEXT.</a:t>
+              <a:t>✓ Completion          ✓ Chat &amp; Agent          ✓ Multi-Agent           → Autonomous</a:t>
+            </a:r>
+          </a:p>
+          <a:p>
+            <a:pPr>
+              <a:spcAft>
+                <a:spcPts val="600"/>
+              </a:spcAft>
+              <a:defRPr sz="1400" b="0">
+                <a:solidFill>
+                  <a:srgbClr val="FFFFFF"/>
+                </a:solidFill>
+              </a:defRPr>
+            </a:pPr>
+            <a:r>
+              <a:t>  Code suggestions      Conversational AI       Orchestration            Full workflow</a:t>
+            </a:r>
+          </a:p>
+        </p:txBody>
+      </p:sp>
+      <p:sp>
+        <p:nvSpPr>
+          <p:cNvPr id="4" name="TextBox 3"/>
+          <p:cNvSpPr txBox="1"/>
+          <p:nvPr/>
+        </p:nvSpPr>
+        <p:spPr>
+          <a:xfrm>
+            <a:off x="457200" y="2286000"/>
+            <a:ext cx="8229600" cy="4572000"/>
+          </a:xfrm>
+          <a:prstGeom prst="rect">
+            <a:avLst/>
+          </a:prstGeom>
+          <a:noFill/>
+        </p:spPr>
+        <p:txBody>
+          <a:bodyPr wrap="square">
+            <a:spAutoFit/>
+          </a:bodyPr>
+          <a:lstStyle/>
+          <a:p>
+            <a:pPr>
+              <a:spcAft>
+                <a:spcPts val="600"/>
+              </a:spcAft>
+              <a:defRPr sz="1400" b="1">
+                <a:solidFill>
+                  <a:srgbClr val="FFA000"/>
+                </a:solidFill>
+              </a:defRPr>
+            </a:pPr>
+            <a:r>
+              <a:t>                                                    ▲</a:t>
+            </a:r>
+          </a:p>
+          <a:p>
+            <a:pPr>
+              <a:spcAft>
+                <a:spcPts val="600"/>
+              </a:spcAft>
+              <a:defRPr sz="1400" b="1">
+                <a:solidFill>
+                  <a:srgbClr val="FFA000"/>
+                </a:solidFill>
+              </a:defRPr>
+            </a:pPr>
+            <a:r>
+              <a:t>                                               WE ARE HERE</a:t>
+            </a:r>
+          </a:p>
+          <a:p>
+            <a:pPr>
+              <a:spcAft>
+                <a:spcPts val="600"/>
+              </a:spcAft>
+              <a:defRPr sz="1400" b="1">
+                <a:solidFill>
+                  <a:srgbClr val="FFA000"/>
+                </a:solidFill>
+              </a:defRPr>
+            </a:pPr>
+            <a:r>
+              <a:t>                                          (natif depuis VS Code 1.109)</a:t>
+            </a:r>
+          </a:p>
+        </p:txBody>
+      </p:sp>
+      <p:sp>
+        <p:nvSpPr>
+          <p:cNvPr id="5" name="TextBox 4"/>
+          <p:cNvSpPr txBox="1"/>
+          <p:nvPr/>
+        </p:nvSpPr>
+        <p:spPr>
+          <a:xfrm>
+            <a:off x="457200" y="3200400"/>
+            <a:ext cx="8229600" cy="4572000"/>
+          </a:xfrm>
+          <a:prstGeom prst="rect">
+            <a:avLst/>
+          </a:prstGeom>
+          <a:noFill/>
+        </p:spPr>
+        <p:txBody>
+          <a:bodyPr wrap="square">
+            <a:spAutoFit/>
+          </a:bodyPr>
+          <a:lstStyle/>
+          <a:p>
+            <a:pPr>
+              <a:spcAft>
+                <a:spcPts val="600"/>
+              </a:spcAft>
+              <a:defRPr sz="1400" b="0">
+                <a:solidFill>
+                  <a:srgbClr val="FFFFFF"/>
+                </a:solidFill>
+              </a:defRPr>
+            </a:pPr>
+            <a:r>
+              <a:t>Ce qui est DÉJÀ disponible :</a:t>
+            </a:r>
+          </a:p>
+          <a:p>
+            <a:pPr>
+              <a:spcAft>
+                <a:spcPts val="600"/>
+              </a:spcAft>
+              <a:defRPr sz="1400" b="0">
+                <a:solidFill>
+                  <a:srgbClr val="FFFFFF"/>
+                </a:solidFill>
+              </a:defRPr>
+            </a:pPr>
+            <a:r>
+              <a:t>  • Agent Sessions View (local / background / cloud)</a:t>
+            </a:r>
+          </a:p>
+          <a:p>
+            <a:pPr>
+              <a:spcAft>
+                <a:spcPts val="600"/>
+              </a:spcAft>
+              <a:defRPr sz="1400" b="0">
+                <a:solidFill>
+                  <a:srgbClr val="FFFFFF"/>
+                </a:solidFill>
+              </a:defRPr>
+            </a:pPr>
+            <a:r>
+              <a:t>  • Subagents parallèles avec contexte isolé</a:t>
+            </a:r>
+          </a:p>
+          <a:p>
+            <a:pPr>
+              <a:spcAft>
+                <a:spcPts val="600"/>
+              </a:spcAft>
+              <a:defRPr sz="1400" b="0">
+                <a:solidFill>
+                  <a:srgbClr val="FFFFFF"/>
+                </a:solidFill>
+              </a:defRPr>
+            </a:pPr>
+            <a:r>
+              <a:t>  • Claude &amp; Codex comme agents natifs</a:t>
+            </a:r>
+          </a:p>
+          <a:p>
+            <a:pPr>
+              <a:spcAft>
+                <a:spcPts val="600"/>
+              </a:spcAft>
+              <a:defRPr sz="1400" b="0">
+                <a:solidFill>
+                  <a:srgbClr val="FFFFFF"/>
+                </a:solidFill>
+              </a:defRPr>
+            </a:pPr>
+            <a:r>
+              <a:t>  • Custom agents avec handoffs automatiques</a:t>
+            </a:r>
+          </a:p>
+          <a:p>
+            <a:pPr>
+              <a:spcAft>
+                <a:spcPts val="600"/>
+              </a:spcAft>
+              <a:defRPr sz="1400" b="0">
+                <a:solidFill>
+                  <a:srgbClr val="FFFFFF"/>
+                </a:solidFill>
+              </a:defRPr>
+            </a:pPr>
+            <a:r>
+              <a:t>  • Agent Skills (standard ouvert — agentskills.io)</a:t>
+            </a:r>
+          </a:p>
+          <a:p>
+            <a:pPr>
+              <a:spcAft>
+                <a:spcPts val="600"/>
+              </a:spcAft>
+              <a:defRPr sz="1400" b="0">
+                <a:solidFill>
+                  <a:srgbClr val="FFFFFF"/>
+                </a:solidFill>
+              </a:defRPr>
+            </a:pPr>
+          </a:p>
+          <a:p>
+            <a:pPr>
+              <a:spcAft>
+                <a:spcPts val="600"/>
+              </a:spcAft>
+              <a:defRPr sz="1400" b="0">
+                <a:solidFill>
+                  <a:srgbClr val="FFFFFF"/>
+                </a:solidFill>
+              </a:defRPr>
+            </a:pPr>
+            <a:r>
+              <a:t>🎯 Orange : industrialiser MAINTENANT nous positionne</a:t>
+            </a:r>
+          </a:p>
+          <a:p>
+            <a:pPr>
+              <a:spcAft>
+                <a:spcPts val="600"/>
+              </a:spcAft>
+              <a:defRPr sz="1400" b="0">
+                <a:solidFill>
+                  <a:srgbClr val="FFFFFF"/>
+                </a:solidFill>
+              </a:defRPr>
+            </a:pPr>
+            <a:r>
+              <a:t>   pour les workflows autonomes de DEMAIN.</a:t>
             </a:r>
           </a:p>
         </p:txBody>
@@ -18130,6 +17637,355 @@
             </a:pPr>
             <a:r>
               <a:t>→ Copilot reproduit le pattern existant avec une consistance parfaite</a:t>
+            </a:r>
+          </a:p>
+        </p:txBody>
+      </p:sp>
+    </p:spTree>
+  </p:cSld>
+  <p:clrMapOvr>
+    <a:masterClrMapping/>
+  </p:clrMapOvr>
+</p:sld>
+</file>
+
+<file path=ppt/slides/slide31.xml><?xml version="1.0" encoding="utf-8"?>
+<p:sld xmlns:a="http://schemas.openxmlformats.org/drawingml/2006/main" xmlns:p="http://schemas.openxmlformats.org/presentationml/2006/main" xmlns:r="http://schemas.openxmlformats.org/officeDocument/2006/relationships">
+  <p:cSld>
+    <p:bg>
+      <p:bgPr>
+        <a:solidFill>
+          <a:srgbClr val="1A1A2E"/>
+        </a:solidFill>
+        <a:effectLst/>
+      </p:bgPr>
+    </p:bg>
+    <p:spTree>
+      <p:nvGrpSpPr>
+        <p:cNvPr id="1" name=""/>
+        <p:cNvGrpSpPr/>
+        <p:nvPr/>
+      </p:nvGrpSpPr>
+      <p:grpSpPr/>
+      <p:sp>
+        <p:nvSpPr>
+          <p:cNvPr id="2" name="TextBox 1"/>
+          <p:cNvSpPr txBox="1"/>
+          <p:nvPr/>
+        </p:nvSpPr>
+        <p:spPr>
+          <a:xfrm>
+            <a:off x="457200" y="274320"/>
+            <a:ext cx="8229600" cy="914400"/>
+          </a:xfrm>
+          <a:prstGeom prst="rect">
+            <a:avLst/>
+          </a:prstGeom>
+          <a:noFill/>
+        </p:spPr>
+        <p:txBody>
+          <a:bodyPr wrap="square">
+            <a:spAutoFit/>
+          </a:bodyPr>
+          <a:lstStyle/>
+          <a:p>
+            <a:pPr>
+              <a:defRPr sz="2800" b="1">
+                <a:solidFill>
+                  <a:srgbClr val="FFFFFF"/>
+                </a:solidFill>
+              </a:defRPr>
+            </a:pPr>
+            <a:r>
+              <a:t>🦴 Caveman Mode — Exercice Live</a:t>
+            </a:r>
+          </a:p>
+        </p:txBody>
+      </p:sp>
+      <p:sp>
+        <p:nvSpPr>
+          <p:cNvPr id="3" name="TextBox 2"/>
+          <p:cNvSpPr txBox="1"/>
+          <p:nvPr/>
+        </p:nvSpPr>
+        <p:spPr>
+          <a:xfrm>
+            <a:off x="457200" y="1188720"/>
+            <a:ext cx="8229600" cy="4572000"/>
+          </a:xfrm>
+          <a:prstGeom prst="rect">
+            <a:avLst/>
+          </a:prstGeom>
+          <a:noFill/>
+        </p:spPr>
+        <p:txBody>
+          <a:bodyPr wrap="square">
+            <a:spAutoFit/>
+          </a:bodyPr>
+          <a:lstStyle/>
+          <a:p>
+            <a:pPr>
+              <a:spcAft>
+                <a:spcPts val="600"/>
+              </a:spcAft>
+              <a:defRPr sz="1500" b="1">
+                <a:solidFill>
+                  <a:srgbClr val="FFFFFF"/>
+                </a:solidFill>
+              </a:defRPr>
+            </a:pPr>
+            <a:r>
+              <a:t>Concept : forcer Copilot à répondre en mode ultra-concis</a:t>
+            </a:r>
+          </a:p>
+          <a:p>
+            <a:pPr>
+              <a:spcAft>
+                <a:spcPts val="600"/>
+              </a:spcAft>
+              <a:defRPr sz="1500" b="1">
+                <a:solidFill>
+                  <a:srgbClr val="FFFFFF"/>
+                </a:solidFill>
+              </a:defRPr>
+            </a:pPr>
+            <a:r>
+              <a:t>Le code reste identique, seul le bavardage est réduit.</a:t>
+            </a:r>
+          </a:p>
+        </p:txBody>
+      </p:sp>
+      <p:sp>
+        <p:nvSpPr>
+          <p:cNvPr id="4" name="TextBox 3"/>
+          <p:cNvSpPr txBox="1"/>
+          <p:nvPr/>
+        </p:nvSpPr>
+        <p:spPr>
+          <a:xfrm>
+            <a:off x="457200" y="2103120"/>
+            <a:ext cx="8229600" cy="4572000"/>
+          </a:xfrm>
+          <a:prstGeom prst="rect">
+            <a:avLst/>
+          </a:prstGeom>
+          <a:noFill/>
+        </p:spPr>
+        <p:txBody>
+          <a:bodyPr wrap="square">
+            <a:spAutoFit/>
+          </a:bodyPr>
+          <a:lstStyle/>
+          <a:p>
+            <a:pPr>
+              <a:spcAft>
+                <a:spcPts val="600"/>
+              </a:spcAft>
+              <a:defRPr sz="1400" b="0">
+                <a:solidFill>
+                  <a:srgbClr val="FFFFFF"/>
+                </a:solidFill>
+              </a:defRPr>
+            </a:pPr>
+            <a:r>
+              <a:t>Installation : .github/skills/caveman-mode/SKILL.md</a:t>
+            </a:r>
+          </a:p>
+          <a:p>
+            <a:pPr>
+              <a:spcAft>
+                <a:spcPts val="600"/>
+              </a:spcAft>
+              <a:defRPr sz="1400" b="0">
+                <a:solidFill>
+                  <a:srgbClr val="FFFFFF"/>
+                </a:solidFill>
+              </a:defRPr>
+            </a:pPr>
+          </a:p>
+          <a:p>
+            <a:pPr>
+              <a:spcAft>
+                <a:spcPts val="600"/>
+              </a:spcAft>
+              <a:defRPr sz="1400" b="0">
+                <a:solidFill>
+                  <a:srgbClr val="FFFFFF"/>
+                </a:solidFill>
+              </a:defRPr>
+            </a:pPr>
+            <a:r>
+              <a:t>Exercice A/B :</a:t>
+            </a:r>
+          </a:p>
+          <a:p>
+            <a:pPr>
+              <a:spcAft>
+                <a:spcPts val="600"/>
+              </a:spcAft>
+              <a:defRPr sz="1400" b="0">
+                <a:solidFill>
+                  <a:srgbClr val="FFFFFF"/>
+                </a:solidFill>
+              </a:defRPr>
+            </a:pPr>
+            <a:r>
+              <a:t>  ❶ SANS Caveman → "Explique le retry" → ~800 tokens</a:t>
+            </a:r>
+          </a:p>
+          <a:p>
+            <a:pPr>
+              <a:spcAft>
+                <a:spcPts val="600"/>
+              </a:spcAft>
+              <a:defRPr sz="1400" b="0">
+                <a:solidFill>
+                  <a:srgbClr val="FFFFFF"/>
+                </a:solidFill>
+              </a:defRPr>
+            </a:pPr>
+            <a:r>
+              <a:t>  ❷ AVEC /caveman-mode → même prompt → ~250 tokens</a:t>
+            </a:r>
+          </a:p>
+          <a:p>
+            <a:pPr>
+              <a:spcAft>
+                <a:spcPts val="600"/>
+              </a:spcAft>
+              <a:defRPr sz="1400" b="0">
+                <a:solidFill>
+                  <a:srgbClr val="FFFFFF"/>
+                </a:solidFill>
+              </a:defRPr>
+            </a:pPr>
+            <a:r>
+              <a:t>  ❸ Générer du code → qualité identique, -65% bavardage</a:t>
+            </a:r>
+          </a:p>
+          <a:p>
+            <a:pPr>
+              <a:spcAft>
+                <a:spcPts val="600"/>
+              </a:spcAft>
+              <a:defRPr sz="1400" b="0">
+                <a:solidFill>
+                  <a:srgbClr val="FFFFFF"/>
+                </a:solidFill>
+              </a:defRPr>
+            </a:pPr>
+          </a:p>
+          <a:p>
+            <a:pPr>
+              <a:spcAft>
+                <a:spcPts val="600"/>
+              </a:spcAft>
+              <a:defRPr sz="1400" b="0">
+                <a:solidFill>
+                  <a:srgbClr val="FFFFFF"/>
+                </a:solidFill>
+              </a:defRPr>
+            </a:pPr>
+            <a:r>
+              <a:t>Résultats :</a:t>
+            </a:r>
+          </a:p>
+          <a:p>
+            <a:pPr>
+              <a:spcAft>
+                <a:spcPts val="600"/>
+              </a:spcAft>
+              <a:defRPr sz="1400" b="0">
+                <a:solidFill>
+                  <a:srgbClr val="FFFFFF"/>
+                </a:solidFill>
+              </a:defRPr>
+            </a:pPr>
+            <a:r>
+              <a:t>  • Explications : -69% tokens</a:t>
+            </a:r>
+          </a:p>
+          <a:p>
+            <a:pPr>
+              <a:spcAft>
+                <a:spcPts val="600"/>
+              </a:spcAft>
+              <a:defRPr sz="1400" b="0">
+                <a:solidFill>
+                  <a:srgbClr val="FFFFFF"/>
+                </a:solidFill>
+              </a:defRPr>
+            </a:pPr>
+            <a:r>
+              <a:t>  • Génération code : -62% tokens</a:t>
+            </a:r>
+          </a:p>
+          <a:p>
+            <a:pPr>
+              <a:spcAft>
+                <a:spcPts val="600"/>
+              </a:spcAft>
+              <a:defRPr sz="1400" b="0">
+                <a:solidFill>
+                  <a:srgbClr val="FFFFFF"/>
+                </a:solidFill>
+              </a:defRPr>
+            </a:pPr>
+            <a:r>
+              <a:t>  • Debug : -67% tokens</a:t>
+            </a:r>
+          </a:p>
+        </p:txBody>
+      </p:sp>
+      <p:sp>
+        <p:nvSpPr>
+          <p:cNvPr id="5" name="TextBox 4"/>
+          <p:cNvSpPr txBox="1"/>
+          <p:nvPr/>
+        </p:nvSpPr>
+        <p:spPr>
+          <a:xfrm>
+            <a:off x="457200" y="5029200"/>
+            <a:ext cx="8229600" cy="4572000"/>
+          </a:xfrm>
+          <a:prstGeom prst="rect">
+            <a:avLst/>
+          </a:prstGeom>
+          <a:noFill/>
+        </p:spPr>
+        <p:txBody>
+          <a:bodyPr wrap="square">
+            <a:spAutoFit/>
+          </a:bodyPr>
+          <a:lstStyle/>
+          <a:p>
+            <a:pPr>
+              <a:spcAft>
+                <a:spcPts val="600"/>
+              </a:spcAft>
+              <a:defRPr sz="1300" b="0">
+                <a:solidFill>
+                  <a:srgbClr val="FFD700"/>
+                </a:solidFill>
+              </a:defRPr>
+            </a:pPr>
+            <a:r>
+              <a:t>💡 Quand l'activer : génération de code, debug rapide, CI</a:t>
+            </a:r>
+          </a:p>
+          <a:p>
+            <a:pPr>
+              <a:spcAft>
+                <a:spcPts val="600"/>
+              </a:spcAft>
+              <a:defRPr sz="1300" b="0">
+                <a:solidFill>
+                  <a:srgbClr val="FFD700"/>
+                </a:solidFill>
+              </a:defRPr>
+            </a:pPr>
+            <a:r>
+              <a:t>❌ Quand NE PAS : apprentissage, exploration, onboarding</a:t>
             </a:r>
           </a:p>
         </p:txBody>

</xml_diff>